<commit_message>
docs: refresh deck screenshots and test counts
</commit_message>
<xml_diff>
--- a/submission/Sponsorship-Gate-Wave2-Pitch-Deck.pptx
+++ b/submission/Sponsorship-Gate-Wave2-Pitch-Deck.pptx
@@ -3557,7 +3557,7 @@
         <p:spPr>
           <a:xfrm>
             <a:off x="594360" y="5074920"/>
-            <a:ext cx="2212848" cy="384048"/>
+            <a:ext cx="2318004" cy="384048"/>
           </a:xfrm>
           <a:prstGeom prst="roundRect">
             <a:avLst>
@@ -3605,7 +3605,7 @@
         <p:spPr>
           <a:xfrm>
             <a:off x="594360" y="5074920"/>
-            <a:ext cx="2212848" cy="384048"/>
+            <a:ext cx="2318004" cy="384048"/>
           </a:xfrm>
           <a:prstGeom prst="rect">
             <a:avLst/>
@@ -3630,7 +3630,7 @@
                 </a:solidFill>
                 <a:latin typeface="Arial"/>
               </a:rPr>
-              <a:t>54 automated tests</a:t>
+              <a:t>70 automated checks</a:t>
             </a:r>
           </a:p>
         </p:txBody>
@@ -3643,7 +3643,7 @@
         </p:nvSpPr>
         <p:spPr>
           <a:xfrm>
-            <a:off x="2990088" y="5074920"/>
+            <a:off x="3095244" y="5074920"/>
             <a:ext cx="2843784" cy="384048"/>
           </a:xfrm>
           <a:prstGeom prst="roundRect">
@@ -3691,7 +3691,7 @@
         </p:nvSpPr>
         <p:spPr>
           <a:xfrm>
-            <a:off x="2990088" y="5074920"/>
+            <a:off x="3095244" y="5074920"/>
             <a:ext cx="2843784" cy="384048"/>
           </a:xfrm>
           <a:prstGeom prst="rect">
@@ -3730,7 +3730,7 @@
         </p:nvSpPr>
         <p:spPr>
           <a:xfrm>
-            <a:off x="6016752" y="5074920"/>
+            <a:off x="6121908" y="5074920"/>
             <a:ext cx="3369564" cy="384048"/>
           </a:xfrm>
           <a:prstGeom prst="roundRect">
@@ -3778,7 +3778,7 @@
         </p:nvSpPr>
         <p:spPr>
           <a:xfrm>
-            <a:off x="6016752" y="5074920"/>
+            <a:off x="6121908" y="5074920"/>
             <a:ext cx="3369564" cy="384048"/>
           </a:xfrm>
           <a:prstGeom prst="rect">
@@ -4115,6 +4115,7 @@
         </p:nvPicPr>
         <p:blipFill>
           <a:blip r:embed="rId2"/>
+          <a:srcRect b="33097"/>
           <a:stretch>
             <a:fillRect/>
           </a:stretch>
@@ -4122,7 +4123,7 @@
         <p:spPr>
           <a:xfrm>
             <a:off x="594360" y="1645920"/>
-            <a:ext cx="3611880" cy="2737128"/>
+            <a:ext cx="3611880" cy="3566160"/>
           </a:xfrm>
           <a:prstGeom prst="rect">
             <a:avLst/>
@@ -4174,7 +4175,7 @@
         </p:nvPicPr>
         <p:blipFill>
           <a:blip r:embed="rId4"/>
-          <a:srcRect b="18359"/>
+          <a:srcRect b="25746"/>
           <a:stretch>
             <a:fillRect/>
           </a:stretch>
@@ -14162,7 +14163,7 @@
                 </a:solidFill>
                 <a:latin typeface="Arial"/>
               </a:rPr>
-              <a:t>20</a:t>
+              <a:t>24</a:t>
             </a:r>
           </a:p>
         </p:txBody>
@@ -14288,7 +14289,7 @@
                 </a:solidFill>
                 <a:latin typeface="Arial"/>
               </a:rPr>
-              <a:t>8</a:t>
+              <a:t>12</a:t>
             </a:r>
           </a:p>
         </p:txBody>

</xml_diff>